<commit_message>
PowerPoint writer: include lang in core document properties.
The lang metadata field was excluded from custom properties but
never written anywhere. Now it is emitted as dc:language in
docProps/core.xml, as in the Docx writer.

Co-Authored-By: Claude Opus 5.5 <noreply@anthropic.com>
</commit_message>
<xml_diff>
--- a/test/pptx/document-properties/output.pptx
+++ b/test/pptx/document-properties/output.pptx
@@ -1,6 +1,6 @@
 
 <file path=ppt/presentation.xml><?xml version="1.0" encoding="utf-8"?>
-<p:presentation xmlns:a="http://schemas.openxmlformats.org/drawingml/2006/main" xmlns:p="http://schemas.openxmlformats.org/presentationml/2006/main" xmlns:r="http://schemas.openxmlformats.org/officeDocument/2006/relationships" autoCompressPictures="0" saveSubsetFonts="1">
+<p:presentation xmlns:a="http://schemas.openxmlformats.org/drawingml/2006/main" xmlns:r="http://schemas.openxmlformats.org/officeDocument/2006/relationships" xmlns:p="http://schemas.openxmlformats.org/presentationml/2006/main" saveSubsetFonts="1" autoCompressPictures="0">
   <p:sldMasterIdLst>
     <p:sldMasterId id="2147483648" r:id="rId1"/>
   </p:sldMasterIdLst>
@@ -14,8 +14,8 @@
     <a:defPPr>
       <a:defRPr lang="en-US"/>
     </a:defPPr>
-    <a:lvl1pPr algn="l" defTabSz="457200" eaLnBrk="1" hangingPunct="1" latinLnBrk="0" marL="0" rtl="0">
-      <a:defRPr kern="1200" sz="1800">
+    <a:lvl1pPr marL="0" algn="l" defTabSz="457200" rtl="0" eaLnBrk="1" latinLnBrk="0" hangingPunct="1">
+      <a:defRPr sz="1800" kern="1200">
         <a:solidFill>
           <a:schemeClr val="tx1"/>
         </a:solidFill>
@@ -24,8 +24,8 @@
         <a:cs typeface="+mn-cs"/>
       </a:defRPr>
     </a:lvl1pPr>
-    <a:lvl2pPr algn="l" defTabSz="457200" eaLnBrk="1" hangingPunct="1" latinLnBrk="0" marL="457200" rtl="0">
-      <a:defRPr kern="1200" sz="1800">
+    <a:lvl2pPr marL="457200" algn="l" defTabSz="457200" rtl="0" eaLnBrk="1" latinLnBrk="0" hangingPunct="1">
+      <a:defRPr sz="1800" kern="1200">
         <a:solidFill>
           <a:schemeClr val="tx1"/>
         </a:solidFill>
@@ -34,8 +34,8 @@
         <a:cs typeface="+mn-cs"/>
       </a:defRPr>
     </a:lvl2pPr>
-    <a:lvl3pPr algn="l" defTabSz="457200" eaLnBrk="1" hangingPunct="1" latinLnBrk="0" marL="914400" rtl="0">
-      <a:defRPr kern="1200" sz="1800">
+    <a:lvl3pPr marL="914400" algn="l" defTabSz="457200" rtl="0" eaLnBrk="1" latinLnBrk="0" hangingPunct="1">
+      <a:defRPr sz="1800" kern="1200">
         <a:solidFill>
           <a:schemeClr val="tx1"/>
         </a:solidFill>
@@ -44,8 +44,8 @@
         <a:cs typeface="+mn-cs"/>
       </a:defRPr>
     </a:lvl3pPr>
-    <a:lvl4pPr algn="l" defTabSz="457200" eaLnBrk="1" hangingPunct="1" latinLnBrk="0" marL="1371600" rtl="0">
-      <a:defRPr kern="1200" sz="1800">
+    <a:lvl4pPr marL="1371600" algn="l" defTabSz="457200" rtl="0" eaLnBrk="1" latinLnBrk="0" hangingPunct="1">
+      <a:defRPr sz="1800" kern="1200">
         <a:solidFill>
           <a:schemeClr val="tx1"/>
         </a:solidFill>
@@ -54,8 +54,8 @@
         <a:cs typeface="+mn-cs"/>
       </a:defRPr>
     </a:lvl4pPr>
-    <a:lvl5pPr algn="l" defTabSz="457200" eaLnBrk="1" hangingPunct="1" latinLnBrk="0" marL="1828800" rtl="0">
-      <a:defRPr kern="1200" sz="1800">
+    <a:lvl5pPr marL="1828800" algn="l" defTabSz="457200" rtl="0" eaLnBrk="1" latinLnBrk="0" hangingPunct="1">
+      <a:defRPr sz="1800" kern="1200">
         <a:solidFill>
           <a:schemeClr val="tx1"/>
         </a:solidFill>
@@ -64,8 +64,8 @@
         <a:cs typeface="+mn-cs"/>
       </a:defRPr>
     </a:lvl5pPr>
-    <a:lvl6pPr algn="l" defTabSz="457200" eaLnBrk="1" hangingPunct="1" latinLnBrk="0" marL="2286000" rtl="0">
-      <a:defRPr kern="1200" sz="1800">
+    <a:lvl6pPr marL="2286000" algn="l" defTabSz="457200" rtl="0" eaLnBrk="1" latinLnBrk="0" hangingPunct="1">
+      <a:defRPr sz="1800" kern="1200">
         <a:solidFill>
           <a:schemeClr val="tx1"/>
         </a:solidFill>
@@ -74,8 +74,8 @@
         <a:cs typeface="+mn-cs"/>
       </a:defRPr>
     </a:lvl6pPr>
-    <a:lvl7pPr algn="l" defTabSz="457200" eaLnBrk="1" hangingPunct="1" latinLnBrk="0" marL="2743200" rtl="0">
-      <a:defRPr kern="1200" sz="1800">
+    <a:lvl7pPr marL="2743200" algn="l" defTabSz="457200" rtl="0" eaLnBrk="1" latinLnBrk="0" hangingPunct="1">
+      <a:defRPr sz="1800" kern="1200">
         <a:solidFill>
           <a:schemeClr val="tx1"/>
         </a:solidFill>
@@ -84,8 +84,8 @@
         <a:cs typeface="+mn-cs"/>
       </a:defRPr>
     </a:lvl7pPr>
-    <a:lvl8pPr algn="l" defTabSz="457200" eaLnBrk="1" hangingPunct="1" latinLnBrk="0" marL="3200400" rtl="0">
-      <a:defRPr kern="1200" sz="1800">
+    <a:lvl8pPr marL="3200400" algn="l" defTabSz="457200" rtl="0" eaLnBrk="1" latinLnBrk="0" hangingPunct="1">
+      <a:defRPr sz="1800" kern="1200">
         <a:solidFill>
           <a:schemeClr val="tx1"/>
         </a:solidFill>
@@ -94,8 +94,8 @@
         <a:cs typeface="+mn-cs"/>
       </a:defRPr>
     </a:lvl8pPr>
-    <a:lvl9pPr algn="l" defTabSz="457200" eaLnBrk="1" hangingPunct="1" latinLnBrk="0" marL="3657600" rtl="0">
-      <a:defRPr kern="1200" sz="1800">
+    <a:lvl9pPr marL="3657600" algn="l" defTabSz="457200" rtl="0" eaLnBrk="1" latinLnBrk="0" hangingPunct="1">
+      <a:defRPr sz="1800" kern="1200">
         <a:solidFill>
           <a:schemeClr val="tx1"/>
         </a:solidFill>
@@ -2567,7 +2567,7 @@
 </file>
 
 <file path=ppt/slideMasters/slideMaster1.xml><?xml version="1.0" encoding="utf-8"?>
-<p:sldMaster xmlns:a="http://schemas.openxmlformats.org/drawingml/2006/main" xmlns:p="http://schemas.openxmlformats.org/presentationml/2006/main" xmlns:r="http://schemas.openxmlformats.org/officeDocument/2006/relationships">
+<p:sldMaster xmlns:a="http://schemas.openxmlformats.org/drawingml/2006/main" xmlns:r="http://schemas.openxmlformats.org/officeDocument/2006/relationships" xmlns:p="http://schemas.openxmlformats.org/presentationml/2006/main">
   <p:cSld>
     <p:bg>
       <p:bgRef idx="1001">
@@ -2608,7 +2608,7 @@
           </a:prstGeom>
         </p:spPr>
         <p:txBody>
-          <a:bodyPr anchor="ctr" bIns="45720" lIns="91440" rIns="91440" rtlCol="0" tIns="45720" vert="horz">
+          <a:bodyPr vert="horz" lIns="91440" tIns="45720" rIns="91440" bIns="45720" rtlCol="0" anchor="ctr">
             <a:normAutofit/>
           </a:bodyPr>
           <a:lstStyle/>
@@ -2627,7 +2627,7 @@
             <a:spLocks noGrp="1"/>
           </p:cNvSpPr>
           <p:nvPr>
-            <p:ph idx="1" type="body"/>
+            <p:ph type="body" idx="1"/>
           </p:nvPr>
         </p:nvSpPr>
         <p:spPr>
@@ -2640,7 +2640,7 @@
           </a:prstGeom>
         </p:spPr>
         <p:txBody>
-          <a:bodyPr bIns="45720" lIns="91440" rIns="91440" rtlCol="0" tIns="45720" vert="horz">
+          <a:bodyPr vert="horz" lIns="91440" tIns="45720" rIns="91440" bIns="45720" rtlCol="0">
             <a:normAutofit/>
           </a:bodyPr>
           <a:lstStyle/>
@@ -2688,7 +2688,7 @@
             <a:spLocks noGrp="1"/>
           </p:cNvSpPr>
           <p:nvPr>
-            <p:ph idx="2" sz="half" type="dt"/>
+            <p:ph type="dt" sz="half" idx="2"/>
           </p:nvPr>
         </p:nvSpPr>
         <p:spPr>
@@ -2701,7 +2701,7 @@
           </a:prstGeom>
         </p:spPr>
         <p:txBody>
-          <a:bodyPr anchor="ctr" bIns="45720" lIns="91440" rIns="91440" rtlCol="0" tIns="45720" vert="horz"/>
+          <a:bodyPr vert="horz" lIns="91440" tIns="45720" rIns="91440" bIns="45720" rtlCol="0" anchor="ctr"/>
           <a:lstStyle>
             <a:lvl1pPr algn="l">
               <a:defRPr sz="900">
@@ -2729,7 +2729,7 @@
             <a:spLocks noGrp="1"/>
           </p:cNvSpPr>
           <p:nvPr>
-            <p:ph idx="3" sz="quarter" type="ftr"/>
+            <p:ph type="ftr" sz="quarter" idx="3"/>
           </p:nvPr>
         </p:nvSpPr>
         <p:spPr>
@@ -2742,7 +2742,7 @@
           </a:prstGeom>
         </p:spPr>
         <p:txBody>
-          <a:bodyPr anchor="ctr" bIns="45720" lIns="91440" rIns="91440" rtlCol="0" tIns="45720" vert="horz"/>
+          <a:bodyPr vert="horz" lIns="91440" tIns="45720" rIns="91440" bIns="45720" rtlCol="0" anchor="ctr"/>
           <a:lstStyle>
             <a:lvl1pPr algn="ctr">
               <a:defRPr sz="900">
@@ -2766,7 +2766,7 @@
             <a:spLocks noGrp="1"/>
           </p:cNvSpPr>
           <p:nvPr>
-            <p:ph idx="4" sz="quarter" type="sldNum"/>
+            <p:ph type="sldNum" sz="quarter" idx="4"/>
           </p:nvPr>
         </p:nvSpPr>
         <p:spPr>
@@ -2779,7 +2779,7 @@
           </a:prstGeom>
         </p:spPr>
         <p:txBody>
-          <a:bodyPr anchor="ctr" bIns="45720" lIns="91440" rIns="91440" rtlCol="0" tIns="45720" vert="horz"/>
+          <a:bodyPr vert="horz" lIns="91440" tIns="45720" rIns="91440" bIns="45720" rtlCol="0" anchor="ctr"/>
           <a:lstStyle>
             <a:lvl1pPr algn="r">
               <a:defRPr sz="900">
@@ -2807,7 +2807,7 @@
       </p:ext>
     </p:extLst>
   </p:cSld>
-  <p:clrMap accent1="accent1" accent2="accent2" accent3="accent3" accent4="accent4" accent5="accent5" accent6="accent6" bg1="lt1" bg2="lt2" folHlink="folHlink" hlink="hlink" tx1="dk1" tx2="dk2"/>
+  <p:clrMap bg1="lt1" tx1="dk1" bg2="lt2" tx2="dk2" accent1="accent1" accent2="accent2" accent3="accent3" accent4="accent4" accent5="accent5" accent6="accent6" hlink="hlink" folHlink="folHlink"/>
   <p:sldLayoutIdLst>
     <p:sldLayoutId id="2147483649" r:id="rId1"/>
     <p:sldLayoutId id="2147483650" r:id="rId2"/>
@@ -2823,12 +2823,12 @@
   </p:sldLayoutIdLst>
   <p:txStyles>
     <p:titleStyle>
-      <a:lvl1pPr algn="ctr" defTabSz="342900" eaLnBrk="1" hangingPunct="1" latinLnBrk="0" rtl="0">
+      <a:lvl1pPr algn="ctr" defTabSz="342900" rtl="0" eaLnBrk="1" latinLnBrk="0" hangingPunct="1">
         <a:spcBef>
           <a:spcPct val="0"/>
         </a:spcBef>
         <a:buNone/>
-        <a:defRPr kern="1200" sz="3300">
+        <a:defRPr sz="3300" kern="1200">
           <a:solidFill>
             <a:schemeClr val="tx1"/>
           </a:solidFill>
@@ -2839,13 +2839,13 @@
       </a:lvl1pPr>
     </p:titleStyle>
     <p:bodyStyle>
-      <a:lvl1pPr algn="l" defTabSz="342900" eaLnBrk="1" hangingPunct="1" indent="-342900" latinLnBrk="0" marL="342900" rtl="0">
+      <a:lvl1pPr marL="342900" indent="-342900" algn="l" defTabSz="342900" rtl="0" eaLnBrk="1" latinLnBrk="0" hangingPunct="1">
         <a:spcBef>
           <a:spcPct val="20000"/>
         </a:spcBef>
         <a:buFont typeface="Arial"/>
         <a:buChar char="•"/>
-        <a:defRPr kern="1200" sz="2400">
+        <a:defRPr sz="2400" kern="1200">
           <a:solidFill>
             <a:schemeClr val="tx1"/>
           </a:solidFill>
@@ -2854,13 +2854,13 @@
           <a:cs typeface="+mn-cs"/>
         </a:defRPr>
       </a:lvl1pPr>
-      <a:lvl2pPr algn="l" defTabSz="342900" eaLnBrk="1" hangingPunct="1" indent="-342900" latinLnBrk="0" marL="685800" rtl="0">
+      <a:lvl2pPr marL="685800" indent="-342900" algn="l" defTabSz="342900" rtl="0" eaLnBrk="1" latinLnBrk="0" hangingPunct="1">
         <a:spcBef>
           <a:spcPct val="20000"/>
         </a:spcBef>
         <a:buFont typeface="Arial"/>
         <a:buChar char="–"/>
-        <a:defRPr kern="1200" sz="2100">
+        <a:defRPr sz="2100" kern="1200">
           <a:solidFill>
             <a:schemeClr val="tx1"/>
           </a:solidFill>
@@ -2869,13 +2869,13 @@
           <a:cs typeface="+mn-cs"/>
         </a:defRPr>
       </a:lvl2pPr>
-      <a:lvl3pPr algn="l" defTabSz="342900" eaLnBrk="1" hangingPunct="1" indent="-342900" latinLnBrk="0" marL="1028700" rtl="0">
+      <a:lvl3pPr marL="1028700" indent="-342900" algn="l" defTabSz="342900" rtl="0" eaLnBrk="1" latinLnBrk="0" hangingPunct="1">
         <a:spcBef>
           <a:spcPct val="20000"/>
         </a:spcBef>
         <a:buFont typeface="Arial"/>
         <a:buChar char="•"/>
-        <a:defRPr kern="1200" sz="1800">
+        <a:defRPr sz="1800" kern="1200">
           <a:solidFill>
             <a:schemeClr val="tx1"/>
           </a:solidFill>
@@ -2884,13 +2884,13 @@
           <a:cs typeface="+mn-cs"/>
         </a:defRPr>
       </a:lvl3pPr>
-      <a:lvl4pPr algn="l" defTabSz="342900" eaLnBrk="1" hangingPunct="1" indent="-342900" latinLnBrk="0" marL="1371600" rtl="0">
+      <a:lvl4pPr marL="1371600" indent="-342900" algn="l" defTabSz="342900" rtl="0" eaLnBrk="1" latinLnBrk="0" hangingPunct="1">
         <a:spcBef>
           <a:spcPct val="20000"/>
         </a:spcBef>
         <a:buFont typeface="Arial"/>
         <a:buChar char="–"/>
-        <a:defRPr kern="1200" sz="1500">
+        <a:defRPr sz="1500" kern="1200">
           <a:solidFill>
             <a:schemeClr val="tx1"/>
           </a:solidFill>
@@ -2899,13 +2899,13 @@
           <a:cs typeface="+mn-cs"/>
         </a:defRPr>
       </a:lvl4pPr>
-      <a:lvl5pPr algn="l" defTabSz="342900" eaLnBrk="1" hangingPunct="1" indent="-342900" latinLnBrk="0" marL="1714500" rtl="0">
+      <a:lvl5pPr marL="1714500" indent="-342900" algn="l" defTabSz="342900" rtl="0" eaLnBrk="1" latinLnBrk="0" hangingPunct="1">
         <a:spcBef>
           <a:spcPct val="20000"/>
         </a:spcBef>
         <a:buFont typeface="Arial"/>
         <a:buChar char="»"/>
-        <a:defRPr kern="1200" sz="1500">
+        <a:defRPr sz="1500" kern="1200">
           <a:solidFill>
             <a:schemeClr val="tx1"/>
           </a:solidFill>
@@ -2914,13 +2914,13 @@
           <a:cs typeface="+mn-cs"/>
         </a:defRPr>
       </a:lvl5pPr>
-      <a:lvl6pPr algn="l" defTabSz="342900" eaLnBrk="1" hangingPunct="1" indent="-342900" latinLnBrk="0" marL="2057400" rtl="0">
+      <a:lvl6pPr marL="2057400" indent="-342900" algn="l" defTabSz="342900" rtl="0" eaLnBrk="1" latinLnBrk="0" hangingPunct="1">
         <a:spcBef>
           <a:spcPct val="20000"/>
         </a:spcBef>
         <a:buFont typeface="Arial"/>
         <a:buChar char="•"/>
-        <a:defRPr kern="1200" sz="1500">
+        <a:defRPr sz="1500" kern="1200">
           <a:solidFill>
             <a:schemeClr val="tx1"/>
           </a:solidFill>
@@ -2929,13 +2929,13 @@
           <a:cs typeface="+mn-cs"/>
         </a:defRPr>
       </a:lvl6pPr>
-      <a:lvl7pPr algn="l" defTabSz="342900" eaLnBrk="1" hangingPunct="1" indent="-342900" latinLnBrk="0" marL="2400300" rtl="0">
+      <a:lvl7pPr marL="2400300" indent="-342900" algn="l" defTabSz="342900" rtl="0" eaLnBrk="1" latinLnBrk="0" hangingPunct="1">
         <a:spcBef>
           <a:spcPct val="20000"/>
         </a:spcBef>
         <a:buFont typeface="Arial"/>
         <a:buChar char="•"/>
-        <a:defRPr kern="1200" sz="1500">
+        <a:defRPr sz="1500" kern="1200">
           <a:solidFill>
             <a:schemeClr val="tx1"/>
           </a:solidFill>
@@ -2944,13 +2944,13 @@
           <a:cs typeface="+mn-cs"/>
         </a:defRPr>
       </a:lvl7pPr>
-      <a:lvl8pPr algn="l" defTabSz="342900" eaLnBrk="1" hangingPunct="1" indent="-342900" latinLnBrk="0" marL="2743200" rtl="0">
+      <a:lvl8pPr marL="2743200" indent="-342900" algn="l" defTabSz="342900" rtl="0" eaLnBrk="1" latinLnBrk="0" hangingPunct="1">
         <a:spcBef>
           <a:spcPct val="20000"/>
         </a:spcBef>
         <a:buFont typeface="Arial"/>
         <a:buChar char="•"/>
-        <a:defRPr kern="1200" sz="1500">
+        <a:defRPr sz="1500" kern="1200">
           <a:solidFill>
             <a:schemeClr val="tx1"/>
           </a:solidFill>
@@ -2959,13 +2959,13 @@
           <a:cs typeface="+mn-cs"/>
         </a:defRPr>
       </a:lvl8pPr>
-      <a:lvl9pPr algn="l" defTabSz="342900" eaLnBrk="1" hangingPunct="1" indent="-342900" latinLnBrk="0" marL="3086100" rtl="0">
+      <a:lvl9pPr marL="3086100" indent="-342900" algn="l" defTabSz="342900" rtl="0" eaLnBrk="1" latinLnBrk="0" hangingPunct="1">
         <a:spcBef>
           <a:spcPct val="20000"/>
         </a:spcBef>
         <a:buFont typeface="Arial"/>
         <a:buChar char="•"/>
-        <a:defRPr kern="1200" sz="1500">
+        <a:defRPr sz="1500" kern="1200">
           <a:solidFill>
             <a:schemeClr val="tx1"/>
           </a:solidFill>
@@ -2979,8 +2979,8 @@
       <a:defPPr>
         <a:defRPr lang="en-US"/>
       </a:defPPr>
-      <a:lvl1pPr algn="l" defTabSz="342900" eaLnBrk="1" hangingPunct="1" latinLnBrk="0" marL="0" rtl="0">
-        <a:defRPr kern="1200" sz="1350">
+      <a:lvl1pPr marL="0" algn="l" defTabSz="342900" rtl="0" eaLnBrk="1" latinLnBrk="0" hangingPunct="1">
+        <a:defRPr sz="1350" kern="1200">
           <a:solidFill>
             <a:schemeClr val="tx1"/>
           </a:solidFill>
@@ -2989,8 +2989,8 @@
           <a:cs typeface="+mn-cs"/>
         </a:defRPr>
       </a:lvl1pPr>
-      <a:lvl2pPr algn="l" defTabSz="342900" eaLnBrk="1" hangingPunct="1" latinLnBrk="0" marL="342900" rtl="0">
-        <a:defRPr kern="1200" sz="1350">
+      <a:lvl2pPr marL="342900" algn="l" defTabSz="342900" rtl="0" eaLnBrk="1" latinLnBrk="0" hangingPunct="1">
+        <a:defRPr sz="1350" kern="1200">
           <a:solidFill>
             <a:schemeClr val="tx1"/>
           </a:solidFill>
@@ -2999,8 +2999,8 @@
           <a:cs typeface="+mn-cs"/>
         </a:defRPr>
       </a:lvl2pPr>
-      <a:lvl3pPr algn="l" defTabSz="342900" eaLnBrk="1" hangingPunct="1" latinLnBrk="0" marL="685800" rtl="0">
-        <a:defRPr kern="1200" sz="1350">
+      <a:lvl3pPr marL="685800" algn="l" defTabSz="342900" rtl="0" eaLnBrk="1" latinLnBrk="0" hangingPunct="1">
+        <a:defRPr sz="1350" kern="1200">
           <a:solidFill>
             <a:schemeClr val="tx1"/>
           </a:solidFill>
@@ -3009,8 +3009,8 @@
           <a:cs typeface="+mn-cs"/>
         </a:defRPr>
       </a:lvl3pPr>
-      <a:lvl4pPr algn="l" defTabSz="342900" eaLnBrk="1" hangingPunct="1" latinLnBrk="0" marL="1028700" rtl="0">
-        <a:defRPr kern="1200" sz="1350">
+      <a:lvl4pPr marL="1028700" algn="l" defTabSz="342900" rtl="0" eaLnBrk="1" latinLnBrk="0" hangingPunct="1">
+        <a:defRPr sz="1350" kern="1200">
           <a:solidFill>
             <a:schemeClr val="tx1"/>
           </a:solidFill>
@@ -3019,8 +3019,8 @@
           <a:cs typeface="+mn-cs"/>
         </a:defRPr>
       </a:lvl4pPr>
-      <a:lvl5pPr algn="l" defTabSz="342900" eaLnBrk="1" hangingPunct="1" latinLnBrk="0" marL="1371600" rtl="0">
-        <a:defRPr kern="1200" sz="1350">
+      <a:lvl5pPr marL="1371600" algn="l" defTabSz="342900" rtl="0" eaLnBrk="1" latinLnBrk="0" hangingPunct="1">
+        <a:defRPr sz="1350" kern="1200">
           <a:solidFill>
             <a:schemeClr val="tx1"/>
           </a:solidFill>
@@ -3029,8 +3029,8 @@
           <a:cs typeface="+mn-cs"/>
         </a:defRPr>
       </a:lvl5pPr>
-      <a:lvl6pPr algn="l" defTabSz="342900" eaLnBrk="1" hangingPunct="1" latinLnBrk="0" marL="1714500" rtl="0">
-        <a:defRPr kern="1200" sz="1350">
+      <a:lvl6pPr marL="1714500" algn="l" defTabSz="342900" rtl="0" eaLnBrk="1" latinLnBrk="0" hangingPunct="1">
+        <a:defRPr sz="1350" kern="1200">
           <a:solidFill>
             <a:schemeClr val="tx1"/>
           </a:solidFill>
@@ -3039,8 +3039,8 @@
           <a:cs typeface="+mn-cs"/>
         </a:defRPr>
       </a:lvl6pPr>
-      <a:lvl7pPr algn="l" defTabSz="342900" eaLnBrk="1" hangingPunct="1" latinLnBrk="0" marL="2057400" rtl="0">
-        <a:defRPr kern="1200" sz="1350">
+      <a:lvl7pPr marL="2057400" algn="l" defTabSz="342900" rtl="0" eaLnBrk="1" latinLnBrk="0" hangingPunct="1">
+        <a:defRPr sz="1350" kern="1200">
           <a:solidFill>
             <a:schemeClr val="tx1"/>
           </a:solidFill>
@@ -3049,8 +3049,8 @@
           <a:cs typeface="+mn-cs"/>
         </a:defRPr>
       </a:lvl7pPr>
-      <a:lvl8pPr algn="l" defTabSz="342900" eaLnBrk="1" hangingPunct="1" latinLnBrk="0" marL="2400300" rtl="0">
-        <a:defRPr kern="1200" sz="1350">
+      <a:lvl8pPr marL="2400300" algn="l" defTabSz="342900" rtl="0" eaLnBrk="1" latinLnBrk="0" hangingPunct="1">
+        <a:defRPr sz="1350" kern="1200">
           <a:solidFill>
             <a:schemeClr val="tx1"/>
           </a:solidFill>
@@ -3059,8 +3059,8 @@
           <a:cs typeface="+mn-cs"/>
         </a:defRPr>
       </a:lvl8pPr>
-      <a:lvl9pPr algn="l" defTabSz="342900" eaLnBrk="1" hangingPunct="1" latinLnBrk="0" marL="2743200" rtl="0">
-        <a:defRPr kern="1200" sz="1350">
+      <a:lvl9pPr marL="2743200" algn="l" defTabSz="342900" rtl="0" eaLnBrk="1" latinLnBrk="0" hangingPunct="1">
+        <a:defRPr sz="1350" kern="1200">
           <a:solidFill>
             <a:schemeClr val="tx1"/>
           </a:solidFill>
@@ -3128,7 +3128,7 @@
             <a:spLocks noGrp="1"/>
           </p:cNvSpPr>
           <p:nvPr>
-            <p:ph idx="1" type="subTitle"/>
+            <p:ph type="subTitle" idx="1"/>
           </p:nvPr>
         </p:nvSpPr>
         <p:spPr>

</xml_diff>